<commit_message>
Report and ppt submit
</commit_message>
<xml_diff>
--- a/Pricing_Forecast_Assessment_Presentation.pptx
+++ b/Pricing_Forecast_Assessment_Presentation.pptx
@@ -130,12 +130,11 @@
 <file path=ppt/revisionInfo.xml><?xml version="1.0" encoding="utf-8"?>
 <p1510:revInfo xmlns:a="http://schemas.openxmlformats.org/drawingml/2006/main" xmlns:r="http://schemas.openxmlformats.org/officeDocument/2006/relationships" xmlns:p1510="http://schemas.microsoft.com/office/powerpoint/2015/10/main">
   <p1510:revLst>
-    <p1510:client id="{00000000-0000-0000-0000-000000000000}" v="275" dt="2026-10-14T04:30:11.797"/>
+    <p1510:client id="{00000000-0000-0000-0000-000000000000}" v="285" dt="2026-10-15T10:29:17.764"/>
     <p1510:client id="{0C20F704-4D9B-6EE2-4FDB-AFCA7C57AC4E}" v="9" dt="2026-10-15T03:29:12.833"/>
     <p1510:client id="{1FFCE5F5-5C85-40EA-A56F-414B3CA7EDB2}" v="159" dt="2026-10-14T04:09:02.770"/>
     <p1510:client id="{200C91C0-FFD4-62BC-0AAF-9FB8B5F9A736}" v="13" dt="2026-10-15T04:43:47.070"/>
     <p1510:client id="{47F2AA4E-CABF-B6DB-FEDA-8367C57FA855}" v="158" dt="2026-10-14T03:39:23.678"/>
-    <p1510:client id="{541B53D7-0F5C-3DE6-3EC9-F25E7BFACF64}" v="14" dt="2026-10-13T07:33:53.952"/>
     <p1510:client id="{7530DC1E-B829-E4EE-B787-0E450E1DCF18}" v="428" dt="2026-10-14T12:13:19.477"/>
     <p1510:client id="{7D14901B-77EE-D7A8-36F9-9870022297F3}" v="15" dt="2026-10-14T08:00:42.264"/>
     <p1510:client id="{D6CFC487-5B0C-B748-F2C1-FE5A511483C8}" v="111" dt="2026-10-14T04:25:25.046"/>
@@ -889,6 +888,30 @@
     </pc:docChg>
   </pc:docChgLst>
   <pc:docChgLst>
+    <pc:chgData name="Guest User" providerId="Windows Live" clId="Web-{00000000-0000-0000-0000-000000000000}"/>
+    <pc:docChg chg="modSld">
+      <pc:chgData name="Guest User" userId="" providerId="Windows Live" clId="Web-{00000000-0000-0000-0000-000000000000}" dt="2026-10-15T10:29:17.764" v="9" actId="20577"/>
+      <pc:docMkLst>
+        <pc:docMk/>
+      </pc:docMkLst>
+      <pc:sldChg chg="modSp">
+        <pc:chgData name="Guest User" userId="" providerId="Windows Live" clId="Web-{00000000-0000-0000-0000-000000000000}" dt="2026-10-15T10:29:17.764" v="9" actId="20577"/>
+        <pc:sldMkLst>
+          <pc:docMk/>
+          <pc:sldMk cId="0" sldId="263"/>
+        </pc:sldMkLst>
+        <pc:spChg chg="mod">
+          <ac:chgData name="Guest User" userId="" providerId="Windows Live" clId="Web-{00000000-0000-0000-0000-000000000000}" dt="2026-10-15T10:29:17.764" v="9" actId="20577"/>
+          <ac:spMkLst>
+            <pc:docMk/>
+            <pc:sldMk cId="0" sldId="263"/>
+            <ac:spMk id="26" creationId="{00000000-0000-0000-0000-000000000000}"/>
+          </ac:spMkLst>
+        </pc:spChg>
+      </pc:sldChg>
+    </pc:docChg>
+  </pc:docChgLst>
+  <pc:docChgLst>
     <pc:chgData name="Zhun Log, Ryan PONG" userId="9b1c450da3d4918e" providerId="Windows Live" clId="Web-{D6CFC487-5B0C-B748-F2C1-FE5A511483C8}"/>
     <pc:docChg chg="addSld modSld">
       <pc:chgData name="Zhun Log, Ryan PONG" userId="9b1c450da3d4918e" providerId="Windows Live" clId="Web-{D6CFC487-5B0C-B748-F2C1-FE5A511483C8}" dt="2026-10-14T04:25:25.046" v="110" actId="1076"/>
@@ -1458,7 +1481,7 @@
           </a:lstStyle>
           <a:p>
             <a:fld id="{8E7E7B10-952C-42AF-A4A0-4F7D2A298A6F}" type="datetimeFigureOut">
-              <a:t>10/14/2026</a:t>
+              <a:t>10/15/2026</a:t>
             </a:fld>
             <a:endParaRPr lang="zh-TW" altLang="en-US"/>
           </a:p>
@@ -20866,21 +20889,44 @@
           <a:bodyPr wrap="square" lIns="0" tIns="0" rIns="0" bIns="0" rtlCol="0" anchor="ctr"/>
           <a:lstStyle/>
           <a:p>
-            <a:pPr marL="0" indent="0">
-              <a:buNone/>
-            </a:pPr>
+            <a:r>
+              <a:rPr lang="en-US" sz="1200" dirty="0">
+                <a:solidFill>
+                  <a:srgbClr val="2C3E50"/>
+                </a:solidFill>
+                <a:latin typeface="Calibri"/>
+                <a:ea typeface="Calibri"/>
+                <a:cs typeface="Calibri"/>
+              </a:rPr>
+              <a:t>• </a:t>
+            </a:r>
             <a:r>
               <a:rPr lang="en-US" sz="1200">
                 <a:solidFill>
                   <a:srgbClr val="2C3E50"/>
                 </a:solidFill>
-                <a:latin typeface="Calibri" pitchFamily="34" charset="0"/>
-                <a:ea typeface="Calibri" pitchFamily="34" charset="-122"/>
-                <a:cs typeface="Calibri" pitchFamily="34" charset="-120"/>
-              </a:rPr>
-              <a:t>• Stacked LSTM + Dropout</a:t>
-            </a:r>
-            <a:endParaRPr lang="en-US" sz="1200"/>
+                <a:latin typeface="Calibri"/>
+                <a:ea typeface="Calibri"/>
+                <a:cs typeface="Calibri"/>
+              </a:rPr>
+              <a:t>Vanilla / Stacked</a:t>
+            </a:r>
+            <a:r>
+              <a:rPr lang="en-US" sz="1200" dirty="0">
+                <a:solidFill>
+                  <a:srgbClr val="2C3E50"/>
+                </a:solidFill>
+                <a:latin typeface="Calibri"/>
+                <a:ea typeface="Calibri"/>
+                <a:cs typeface="Calibri"/>
+              </a:rPr>
+              <a:t> LSTM + Dropout</a:t>
+            </a:r>
+            <a:endParaRPr lang="en-US" sz="1200" dirty="0">
+              <a:latin typeface="Calibri"/>
+              <a:ea typeface="Calibri"/>
+              <a:cs typeface="Calibri"/>
+            </a:endParaRPr>
           </a:p>
           <a:p>
             <a:pPr marL="0" indent="0">

</xml_diff>